<commit_message>
Add card, Help and Report img
</commit_message>
<xml_diff>
--- a/Sales-performance-report/dataset/designbackground.pptx
+++ b/Sales-performance-report/dataset/designbackground.pptx
@@ -6,7 +6,10 @@
   </p:sldMasterIdLst>
   <p:sldIdLst>
     <p:sldId id="256" r:id="rId2"/>
-    <p:sldId id="257" r:id="rId3"/>
+    <p:sldId id="258" r:id="rId3"/>
+    <p:sldId id="259" r:id="rId4"/>
+    <p:sldId id="260" r:id="rId5"/>
+    <p:sldId id="257" r:id="rId6"/>
   </p:sldIdLst>
   <p:sldSz cx="13716000" cy="9144000"/>
   <p:notesSz cx="6858000" cy="9144000"/>
@@ -108,7 +111,7 @@
   <p:extLst>
     <p:ext uri="{EFAFB233-063F-42B5-8137-9DF3F51BA10A}">
       <p15:sldGuideLst xmlns:p15="http://schemas.microsoft.com/office/powerpoint/2012/main">
-        <p15:guide id="1" orient="horz" pos="2880" userDrawn="1">
+        <p15:guide id="1" orient="horz" pos="2856" userDrawn="1">
           <p15:clr>
             <a:srgbClr val="A4A3A4"/>
           </p15:clr>
@@ -255,7 +258,7 @@
           <a:p>
             <a:fld id="{073D55F9-11A3-4523-8F38-6BA37933791A}" type="datetime1">
               <a:rPr lang="en-US" smtClean="0"/>
-              <a:t>12/27/2025</a:t>
+              <a:t>12/28/2025</a:t>
             </a:fld>
             <a:endParaRPr lang="en-US"/>
           </a:p>
@@ -428,7 +431,7 @@
           <a:p>
             <a:fld id="{0B4E757A-3EC2-4683-9080-1A460C37C843}" type="datetime1">
               <a:rPr lang="en-US" smtClean="0"/>
-              <a:t>12/27/2025</a:t>
+              <a:t>12/28/2025</a:t>
             </a:fld>
             <a:endParaRPr lang="en-US"/>
           </a:p>
@@ -611,7 +614,7 @@
           <a:p>
             <a:fld id="{5CC8096C-64ED-4153-A483-5C02E44AD5C3}" type="datetime1">
               <a:rPr lang="en-US" smtClean="0"/>
-              <a:t>12/27/2025</a:t>
+              <a:t>12/28/2025</a:t>
             </a:fld>
             <a:endParaRPr lang="en-US" dirty="0"/>
           </a:p>
@@ -784,7 +787,7 @@
           <a:p>
             <a:fld id="{1CB9D56B-6EBE-4E5F-99D9-2A3DBDF37D0A}" type="datetime1">
               <a:rPr lang="en-US" smtClean="0"/>
-              <a:t>12/27/2025</a:t>
+              <a:t>12/28/2025</a:t>
             </a:fld>
             <a:endParaRPr lang="en-US"/>
           </a:p>
@@ -1033,7 +1036,7 @@
           <a:p>
             <a:fld id="{8C33F3CA-C7E3-432D-9282-18F13836509A}" type="datetime1">
               <a:rPr lang="en-US" smtClean="0"/>
-              <a:t>12/27/2025</a:t>
+              <a:t>12/28/2025</a:t>
             </a:fld>
             <a:endParaRPr lang="en-US" dirty="0"/>
           </a:p>
@@ -1268,7 +1271,7 @@
           <a:p>
             <a:fld id="{75BE9C62-1337-40B8-BA50-E9F4861DB4BC}" type="datetime1">
               <a:rPr lang="en-US" smtClean="0"/>
-              <a:t>12/27/2025</a:t>
+              <a:t>12/28/2025</a:t>
             </a:fld>
             <a:endParaRPr lang="en-US"/>
           </a:p>
@@ -1638,7 +1641,7 @@
           <a:p>
             <a:fld id="{47C195EB-2DA3-4B24-8725-19BC22A7BE50}" type="datetime1">
               <a:rPr lang="en-US" smtClean="0"/>
-              <a:t>12/27/2025</a:t>
+              <a:t>12/28/2025</a:t>
             </a:fld>
             <a:endParaRPr lang="en-US"/>
           </a:p>
@@ -1759,7 +1762,7 @@
           <a:p>
             <a:fld id="{F4E237E6-0076-4915-A5A8-B7C11FA4F374}" type="datetime1">
               <a:rPr lang="en-US" smtClean="0"/>
-              <a:t>12/27/2025</a:t>
+              <a:t>12/28/2025</a:t>
             </a:fld>
             <a:endParaRPr lang="en-US"/>
           </a:p>
@@ -1857,7 +1860,7 @@
           <a:p>
             <a:fld id="{3505F58F-C0B5-422A-8E5A-6B99E5D80F0A}" type="datetime1">
               <a:rPr lang="en-US" smtClean="0"/>
-              <a:t>12/27/2025</a:t>
+              <a:t>12/28/2025</a:t>
             </a:fld>
             <a:endParaRPr lang="en-US"/>
           </a:p>
@@ -2137,7 +2140,7 @@
           <a:p>
             <a:fld id="{7565E655-9687-48DF-A33F-F8824CCCB5D1}" type="datetime1">
               <a:rPr lang="en-US" smtClean="0"/>
-              <a:t>12/27/2025</a:t>
+              <a:t>12/28/2025</a:t>
             </a:fld>
             <a:endParaRPr lang="en-US"/>
           </a:p>
@@ -2397,7 +2400,7 @@
           <a:p>
             <a:fld id="{B97FD56A-AAB8-4544-A495-D0645413C9E3}" type="datetime1">
               <a:rPr lang="en-US" smtClean="0"/>
-              <a:t>12/27/2025</a:t>
+              <a:t>12/28/2025</a:t>
             </a:fld>
             <a:endParaRPr lang="en-US"/>
           </a:p>
@@ -2614,7 +2617,7 @@
             <a:fld id="{193BAB95-8DA7-460B-B00A-7037C8394FB0}" type="datetime1">
               <a:rPr lang="en-US" smtClean="0"/>
               <a:pPr/>
-              <a:t>12/27/2025</a:t>
+              <a:t>12/28/2025</a:t>
             </a:fld>
             <a:endParaRPr lang="en-US" dirty="0"/>
           </a:p>
@@ -3856,6 +3859,1257 @@
       </p:grpSpPr>
       <p:sp>
         <p:nvSpPr>
+          <p:cNvPr id="5" name="Rectangle 4">
+            <a:extLst>
+              <a:ext uri="{FF2B5EF4-FFF2-40B4-BE49-F238E27FC236}">
+                <a16:creationId xmlns:a16="http://schemas.microsoft.com/office/drawing/2014/main" id="{CE36F0A6-51B5-EF9A-4B26-459E88BC981B}"/>
+              </a:ext>
+            </a:extLst>
+          </p:cNvPr>
+          <p:cNvSpPr/>
+          <p:nvPr/>
+        </p:nvSpPr>
+        <p:spPr>
+          <a:xfrm>
+            <a:off x="0" y="0"/>
+            <a:ext cx="13716000" cy="9144000"/>
+          </a:xfrm>
+          <a:prstGeom prst="rect">
+            <a:avLst/>
+          </a:prstGeom>
+          <a:solidFill>
+            <a:srgbClr val="ECEAF7"/>
+          </a:solidFill>
+          <a:ln>
+            <a:noFill/>
+          </a:ln>
+        </p:spPr>
+        <p:style>
+          <a:lnRef idx="2">
+            <a:schemeClr val="accent1">
+              <a:shade val="15000"/>
+            </a:schemeClr>
+          </a:lnRef>
+          <a:fillRef idx="1">
+            <a:schemeClr val="accent1"/>
+          </a:fillRef>
+          <a:effectRef idx="0">
+            <a:schemeClr val="accent1"/>
+          </a:effectRef>
+          <a:fontRef idx="minor">
+            <a:schemeClr val="lt1"/>
+          </a:fontRef>
+        </p:style>
+        <p:txBody>
+          <a:bodyPr rtlCol="0" anchor="ctr"/>
+          <a:lstStyle/>
+          <a:p>
+            <a:pPr algn="ctr"/>
+            <a:endParaRPr lang="en-US" dirty="0"/>
+          </a:p>
+        </p:txBody>
+      </p:sp>
+      <p:sp>
+        <p:nvSpPr>
+          <p:cNvPr id="7" name="Rectangle 6">
+            <a:extLst>
+              <a:ext uri="{FF2B5EF4-FFF2-40B4-BE49-F238E27FC236}">
+                <a16:creationId xmlns:a16="http://schemas.microsoft.com/office/drawing/2014/main" id="{D5E83209-DC62-B6FB-5834-E8D592C370CF}"/>
+              </a:ext>
+            </a:extLst>
+          </p:cNvPr>
+          <p:cNvSpPr/>
+          <p:nvPr/>
+        </p:nvSpPr>
+        <p:spPr>
+          <a:xfrm>
+            <a:off x="0" y="0"/>
+            <a:ext cx="13716000" cy="685800"/>
+          </a:xfrm>
+          <a:prstGeom prst="rect">
+            <a:avLst/>
+          </a:prstGeom>
+          <a:solidFill>
+            <a:schemeClr val="bg1"/>
+          </a:solidFill>
+          <a:ln>
+            <a:noFill/>
+          </a:ln>
+        </p:spPr>
+        <p:style>
+          <a:lnRef idx="2">
+            <a:schemeClr val="accent1">
+              <a:shade val="15000"/>
+            </a:schemeClr>
+          </a:lnRef>
+          <a:fillRef idx="1">
+            <a:schemeClr val="accent1"/>
+          </a:fillRef>
+          <a:effectRef idx="0">
+            <a:schemeClr val="accent1"/>
+          </a:effectRef>
+          <a:fontRef idx="minor">
+            <a:schemeClr val="lt1"/>
+          </a:fontRef>
+        </p:style>
+        <p:txBody>
+          <a:bodyPr rtlCol="0" anchor="ctr"/>
+          <a:lstStyle/>
+          <a:p>
+            <a:pPr algn="ctr"/>
+            <a:endParaRPr lang="en-US"/>
+          </a:p>
+        </p:txBody>
+      </p:sp>
+      <p:sp>
+        <p:nvSpPr>
+          <p:cNvPr id="6" name="Rectangle 5">
+            <a:extLst>
+              <a:ext uri="{FF2B5EF4-FFF2-40B4-BE49-F238E27FC236}">
+                <a16:creationId xmlns:a16="http://schemas.microsoft.com/office/drawing/2014/main" id="{DAC39EE8-1658-6F0D-AA9C-A926CD1A0079}"/>
+              </a:ext>
+            </a:extLst>
+          </p:cNvPr>
+          <p:cNvSpPr/>
+          <p:nvPr/>
+        </p:nvSpPr>
+        <p:spPr>
+          <a:xfrm>
+            <a:off x="0" y="0"/>
+            <a:ext cx="1920240" cy="9144000"/>
+          </a:xfrm>
+          <a:prstGeom prst="rect">
+            <a:avLst/>
+          </a:prstGeom>
+          <a:gradFill>
+            <a:gsLst>
+              <a:gs pos="74845">
+                <a:srgbClr val="9B73FF"/>
+              </a:gs>
+              <a:gs pos="54000">
+                <a:srgbClr val="4C05FF"/>
+              </a:gs>
+              <a:gs pos="100000">
+                <a:schemeClr val="bg1"/>
+              </a:gs>
+            </a:gsLst>
+            <a:lin ang="5400000" scaled="1"/>
+          </a:gradFill>
+          <a:ln>
+            <a:noFill/>
+          </a:ln>
+        </p:spPr>
+        <p:style>
+          <a:lnRef idx="2">
+            <a:schemeClr val="accent1">
+              <a:shade val="15000"/>
+            </a:schemeClr>
+          </a:lnRef>
+          <a:fillRef idx="1">
+            <a:schemeClr val="accent1"/>
+          </a:fillRef>
+          <a:effectRef idx="0">
+            <a:schemeClr val="accent1"/>
+          </a:effectRef>
+          <a:fontRef idx="minor">
+            <a:schemeClr val="lt1"/>
+          </a:fontRef>
+        </p:style>
+        <p:txBody>
+          <a:bodyPr rtlCol="0" anchor="ctr"/>
+          <a:lstStyle/>
+          <a:p>
+            <a:pPr algn="ctr"/>
+            <a:endParaRPr lang="en-US"/>
+          </a:p>
+        </p:txBody>
+      </p:sp>
+      <p:sp>
+        <p:nvSpPr>
+          <p:cNvPr id="2" name="Rectangle: Rounded Corners 1">
+            <a:extLst>
+              <a:ext uri="{FF2B5EF4-FFF2-40B4-BE49-F238E27FC236}">
+                <a16:creationId xmlns:a16="http://schemas.microsoft.com/office/drawing/2014/main" id="{D5F3C42B-EF6B-EA4C-850F-E567F95C3888}"/>
+              </a:ext>
+            </a:extLst>
+          </p:cNvPr>
+          <p:cNvSpPr/>
+          <p:nvPr/>
+        </p:nvSpPr>
+        <p:spPr>
+          <a:xfrm>
+            <a:off x="2377440" y="942702"/>
+            <a:ext cx="2551176" cy="1600200"/>
+          </a:xfrm>
+          <a:prstGeom prst="roundRect">
+            <a:avLst>
+              <a:gd name="adj" fmla="val 6362"/>
+            </a:avLst>
+          </a:prstGeom>
+          <a:solidFill>
+            <a:schemeClr val="bg1"/>
+          </a:solidFill>
+          <a:ln>
+            <a:noFill/>
+          </a:ln>
+          <a:effectLst>
+            <a:outerShdw blurRad="190500" dist="38100" dir="5400000" algn="t" rotWithShape="0">
+              <a:prstClr val="black">
+                <a:alpha val="15000"/>
+              </a:prstClr>
+            </a:outerShdw>
+          </a:effectLst>
+        </p:spPr>
+        <p:style>
+          <a:lnRef idx="2">
+            <a:schemeClr val="accent1">
+              <a:shade val="15000"/>
+            </a:schemeClr>
+          </a:lnRef>
+          <a:fillRef idx="1">
+            <a:schemeClr val="accent1"/>
+          </a:fillRef>
+          <a:effectRef idx="0">
+            <a:schemeClr val="accent1"/>
+          </a:effectRef>
+          <a:fontRef idx="minor">
+            <a:schemeClr val="lt1"/>
+          </a:fontRef>
+        </p:style>
+        <p:txBody>
+          <a:bodyPr rtlCol="0" anchor="ctr"/>
+          <a:lstStyle/>
+          <a:p>
+            <a:pPr algn="ctr"/>
+            <a:endParaRPr lang="en-US" dirty="0"/>
+          </a:p>
+        </p:txBody>
+      </p:sp>
+      <p:sp>
+        <p:nvSpPr>
+          <p:cNvPr id="17" name="Rectangle: Rounded Corners 16">
+            <a:extLst>
+              <a:ext uri="{FF2B5EF4-FFF2-40B4-BE49-F238E27FC236}">
+                <a16:creationId xmlns:a16="http://schemas.microsoft.com/office/drawing/2014/main" id="{2AA8D939-A5CC-234E-32E5-3527FE82E280}"/>
+              </a:ext>
+            </a:extLst>
+          </p:cNvPr>
+          <p:cNvSpPr/>
+          <p:nvPr/>
+        </p:nvSpPr>
+        <p:spPr>
+          <a:xfrm>
+            <a:off x="5154168" y="942702"/>
+            <a:ext cx="2551176" cy="1600200"/>
+          </a:xfrm>
+          <a:prstGeom prst="roundRect">
+            <a:avLst>
+              <a:gd name="adj" fmla="val 6362"/>
+            </a:avLst>
+          </a:prstGeom>
+          <a:solidFill>
+            <a:schemeClr val="bg1"/>
+          </a:solidFill>
+          <a:ln>
+            <a:noFill/>
+          </a:ln>
+          <a:effectLst>
+            <a:outerShdw blurRad="190500" dist="38100" dir="5400000" algn="t" rotWithShape="0">
+              <a:prstClr val="black">
+                <a:alpha val="15000"/>
+              </a:prstClr>
+            </a:outerShdw>
+          </a:effectLst>
+        </p:spPr>
+        <p:style>
+          <a:lnRef idx="2">
+            <a:schemeClr val="accent1">
+              <a:shade val="15000"/>
+            </a:schemeClr>
+          </a:lnRef>
+          <a:fillRef idx="1">
+            <a:schemeClr val="accent1"/>
+          </a:fillRef>
+          <a:effectRef idx="0">
+            <a:schemeClr val="accent1"/>
+          </a:effectRef>
+          <a:fontRef idx="minor">
+            <a:schemeClr val="lt1"/>
+          </a:fontRef>
+        </p:style>
+        <p:txBody>
+          <a:bodyPr rtlCol="0" anchor="ctr"/>
+          <a:lstStyle/>
+          <a:p>
+            <a:pPr algn="ctr"/>
+            <a:endParaRPr lang="en-US" dirty="0"/>
+          </a:p>
+        </p:txBody>
+      </p:sp>
+      <p:sp>
+        <p:nvSpPr>
+          <p:cNvPr id="18" name="Rectangle: Rounded Corners 17">
+            <a:extLst>
+              <a:ext uri="{FF2B5EF4-FFF2-40B4-BE49-F238E27FC236}">
+                <a16:creationId xmlns:a16="http://schemas.microsoft.com/office/drawing/2014/main" id="{A44D49B4-63A2-2A10-8A94-FD359FE00E43}"/>
+              </a:ext>
+            </a:extLst>
+          </p:cNvPr>
+          <p:cNvSpPr/>
+          <p:nvPr/>
+        </p:nvSpPr>
+        <p:spPr>
+          <a:xfrm>
+            <a:off x="7930896" y="942702"/>
+            <a:ext cx="2551176" cy="1600200"/>
+          </a:xfrm>
+          <a:prstGeom prst="roundRect">
+            <a:avLst>
+              <a:gd name="adj" fmla="val 6362"/>
+            </a:avLst>
+          </a:prstGeom>
+          <a:solidFill>
+            <a:schemeClr val="bg1"/>
+          </a:solidFill>
+          <a:ln>
+            <a:noFill/>
+          </a:ln>
+          <a:effectLst>
+            <a:outerShdw blurRad="190500" dist="38100" dir="5400000" algn="t" rotWithShape="0">
+              <a:prstClr val="black">
+                <a:alpha val="15000"/>
+              </a:prstClr>
+            </a:outerShdw>
+          </a:effectLst>
+        </p:spPr>
+        <p:style>
+          <a:lnRef idx="2">
+            <a:schemeClr val="accent1">
+              <a:shade val="15000"/>
+            </a:schemeClr>
+          </a:lnRef>
+          <a:fillRef idx="1">
+            <a:schemeClr val="accent1"/>
+          </a:fillRef>
+          <a:effectRef idx="0">
+            <a:schemeClr val="accent1"/>
+          </a:effectRef>
+          <a:fontRef idx="minor">
+            <a:schemeClr val="lt1"/>
+          </a:fontRef>
+        </p:style>
+        <p:txBody>
+          <a:bodyPr rtlCol="0" anchor="ctr"/>
+          <a:lstStyle/>
+          <a:p>
+            <a:pPr algn="ctr"/>
+            <a:endParaRPr lang="en-US" dirty="0"/>
+          </a:p>
+        </p:txBody>
+      </p:sp>
+      <p:sp>
+        <p:nvSpPr>
+          <p:cNvPr id="19" name="Rectangle: Rounded Corners 18">
+            <a:extLst>
+              <a:ext uri="{FF2B5EF4-FFF2-40B4-BE49-F238E27FC236}">
+                <a16:creationId xmlns:a16="http://schemas.microsoft.com/office/drawing/2014/main" id="{9CE7F832-AC53-EB58-BF19-E8B89D29CE77}"/>
+              </a:ext>
+            </a:extLst>
+          </p:cNvPr>
+          <p:cNvSpPr/>
+          <p:nvPr/>
+        </p:nvSpPr>
+        <p:spPr>
+          <a:xfrm>
+            <a:off x="10707624" y="942702"/>
+            <a:ext cx="2551176" cy="1600200"/>
+          </a:xfrm>
+          <a:prstGeom prst="roundRect">
+            <a:avLst>
+              <a:gd name="adj" fmla="val 6362"/>
+            </a:avLst>
+          </a:prstGeom>
+          <a:solidFill>
+            <a:schemeClr val="bg1"/>
+          </a:solidFill>
+          <a:ln>
+            <a:noFill/>
+          </a:ln>
+          <a:effectLst>
+            <a:outerShdw blurRad="190500" dist="38100" dir="5400000" algn="t" rotWithShape="0">
+              <a:prstClr val="black">
+                <a:alpha val="15000"/>
+              </a:prstClr>
+            </a:outerShdw>
+          </a:effectLst>
+        </p:spPr>
+        <p:style>
+          <a:lnRef idx="2">
+            <a:schemeClr val="accent1">
+              <a:shade val="15000"/>
+            </a:schemeClr>
+          </a:lnRef>
+          <a:fillRef idx="1">
+            <a:schemeClr val="accent1"/>
+          </a:fillRef>
+          <a:effectRef idx="0">
+            <a:schemeClr val="accent1"/>
+          </a:effectRef>
+          <a:fontRef idx="minor">
+            <a:schemeClr val="lt1"/>
+          </a:fontRef>
+        </p:style>
+        <p:txBody>
+          <a:bodyPr rtlCol="0" anchor="ctr"/>
+          <a:lstStyle/>
+          <a:p>
+            <a:pPr algn="ctr"/>
+            <a:endParaRPr lang="en-US" dirty="0"/>
+          </a:p>
+        </p:txBody>
+      </p:sp>
+      <p:sp>
+        <p:nvSpPr>
+          <p:cNvPr id="21" name="Rectangle: Rounded Corners 20">
+            <a:extLst>
+              <a:ext uri="{FF2B5EF4-FFF2-40B4-BE49-F238E27FC236}">
+                <a16:creationId xmlns:a16="http://schemas.microsoft.com/office/drawing/2014/main" id="{4D0B78BB-6C10-95CA-3935-16CB72110E7C}"/>
+              </a:ext>
+            </a:extLst>
+          </p:cNvPr>
+          <p:cNvSpPr/>
+          <p:nvPr/>
+        </p:nvSpPr>
+        <p:spPr>
+          <a:xfrm>
+            <a:off x="2377440" y="2771501"/>
+            <a:ext cx="6618732" cy="2971800"/>
+          </a:xfrm>
+          <a:prstGeom prst="roundRect">
+            <a:avLst>
+              <a:gd name="adj" fmla="val 6362"/>
+            </a:avLst>
+          </a:prstGeom>
+          <a:solidFill>
+            <a:schemeClr val="bg1"/>
+          </a:solidFill>
+          <a:ln>
+            <a:noFill/>
+          </a:ln>
+          <a:effectLst>
+            <a:outerShdw blurRad="190500" dist="38100" dir="5400000" algn="t" rotWithShape="0">
+              <a:prstClr val="black">
+                <a:alpha val="15000"/>
+              </a:prstClr>
+            </a:outerShdw>
+          </a:effectLst>
+        </p:spPr>
+        <p:style>
+          <a:lnRef idx="2">
+            <a:schemeClr val="accent1">
+              <a:shade val="15000"/>
+            </a:schemeClr>
+          </a:lnRef>
+          <a:fillRef idx="1">
+            <a:schemeClr val="accent1"/>
+          </a:fillRef>
+          <a:effectRef idx="0">
+            <a:schemeClr val="accent1"/>
+          </a:effectRef>
+          <a:fontRef idx="minor">
+            <a:schemeClr val="lt1"/>
+          </a:fontRef>
+        </p:style>
+        <p:txBody>
+          <a:bodyPr rtlCol="0" anchor="ctr"/>
+          <a:lstStyle/>
+          <a:p>
+            <a:pPr algn="ctr"/>
+            <a:endParaRPr lang="en-US" dirty="0"/>
+          </a:p>
+        </p:txBody>
+      </p:sp>
+      <p:sp>
+        <p:nvSpPr>
+          <p:cNvPr id="22" name="Rectangle: Rounded Corners 21">
+            <a:extLst>
+              <a:ext uri="{FF2B5EF4-FFF2-40B4-BE49-F238E27FC236}">
+                <a16:creationId xmlns:a16="http://schemas.microsoft.com/office/drawing/2014/main" id="{11044C76-A2BA-C664-EE44-BB825D1DE81E}"/>
+              </a:ext>
+            </a:extLst>
+          </p:cNvPr>
+          <p:cNvSpPr/>
+          <p:nvPr/>
+        </p:nvSpPr>
+        <p:spPr>
+          <a:xfrm>
+            <a:off x="9224772" y="2771501"/>
+            <a:ext cx="4034028" cy="2971800"/>
+          </a:xfrm>
+          <a:prstGeom prst="roundRect">
+            <a:avLst>
+              <a:gd name="adj" fmla="val 6362"/>
+            </a:avLst>
+          </a:prstGeom>
+          <a:solidFill>
+            <a:schemeClr val="bg1"/>
+          </a:solidFill>
+          <a:ln>
+            <a:noFill/>
+          </a:ln>
+          <a:effectLst>
+            <a:outerShdw blurRad="190500" dist="38100" dir="5400000" algn="t" rotWithShape="0">
+              <a:prstClr val="black">
+                <a:alpha val="15000"/>
+              </a:prstClr>
+            </a:outerShdw>
+          </a:effectLst>
+        </p:spPr>
+        <p:style>
+          <a:lnRef idx="2">
+            <a:schemeClr val="accent1">
+              <a:shade val="15000"/>
+            </a:schemeClr>
+          </a:lnRef>
+          <a:fillRef idx="1">
+            <a:schemeClr val="accent1"/>
+          </a:fillRef>
+          <a:effectRef idx="0">
+            <a:schemeClr val="accent1"/>
+          </a:effectRef>
+          <a:fontRef idx="minor">
+            <a:schemeClr val="lt1"/>
+          </a:fontRef>
+        </p:style>
+        <p:txBody>
+          <a:bodyPr rtlCol="0" anchor="ctr"/>
+          <a:lstStyle/>
+          <a:p>
+            <a:pPr algn="ctr"/>
+            <a:endParaRPr lang="en-US" dirty="0"/>
+          </a:p>
+        </p:txBody>
+      </p:sp>
+      <p:sp>
+        <p:nvSpPr>
+          <p:cNvPr id="29" name="Rectangle: Rounded Corners 28">
+            <a:extLst>
+              <a:ext uri="{FF2B5EF4-FFF2-40B4-BE49-F238E27FC236}">
+                <a16:creationId xmlns:a16="http://schemas.microsoft.com/office/drawing/2014/main" id="{AFCD7A3B-524E-8B41-B3FF-1676DB7821F0}"/>
+              </a:ext>
+            </a:extLst>
+          </p:cNvPr>
+          <p:cNvSpPr/>
+          <p:nvPr/>
+        </p:nvSpPr>
+        <p:spPr>
+          <a:xfrm>
+            <a:off x="6640068" y="5971900"/>
+            <a:ext cx="6618732" cy="2971800"/>
+          </a:xfrm>
+          <a:prstGeom prst="roundRect">
+            <a:avLst>
+              <a:gd name="adj" fmla="val 6362"/>
+            </a:avLst>
+          </a:prstGeom>
+          <a:solidFill>
+            <a:schemeClr val="bg1"/>
+          </a:solidFill>
+          <a:ln>
+            <a:noFill/>
+          </a:ln>
+          <a:effectLst>
+            <a:outerShdw blurRad="190500" dist="38100" dir="5400000" algn="t" rotWithShape="0">
+              <a:prstClr val="black">
+                <a:alpha val="15000"/>
+              </a:prstClr>
+            </a:outerShdw>
+          </a:effectLst>
+        </p:spPr>
+        <p:style>
+          <a:lnRef idx="2">
+            <a:schemeClr val="accent1">
+              <a:shade val="15000"/>
+            </a:schemeClr>
+          </a:lnRef>
+          <a:fillRef idx="1">
+            <a:schemeClr val="accent1"/>
+          </a:fillRef>
+          <a:effectRef idx="0">
+            <a:schemeClr val="accent1"/>
+          </a:effectRef>
+          <a:fontRef idx="minor">
+            <a:schemeClr val="lt1"/>
+          </a:fontRef>
+        </p:style>
+        <p:txBody>
+          <a:bodyPr rtlCol="0" anchor="ctr"/>
+          <a:lstStyle/>
+          <a:p>
+            <a:pPr algn="ctr"/>
+            <a:endParaRPr lang="en-US" dirty="0"/>
+          </a:p>
+        </p:txBody>
+      </p:sp>
+      <p:sp>
+        <p:nvSpPr>
+          <p:cNvPr id="30" name="Rectangle: Rounded Corners 29">
+            <a:extLst>
+              <a:ext uri="{FF2B5EF4-FFF2-40B4-BE49-F238E27FC236}">
+                <a16:creationId xmlns:a16="http://schemas.microsoft.com/office/drawing/2014/main" id="{64E1A75F-9F0C-0F5F-9F19-1A73C2237C37}"/>
+              </a:ext>
+            </a:extLst>
+          </p:cNvPr>
+          <p:cNvSpPr/>
+          <p:nvPr/>
+        </p:nvSpPr>
+        <p:spPr>
+          <a:xfrm>
+            <a:off x="2377440" y="5971900"/>
+            <a:ext cx="4034028" cy="2971800"/>
+          </a:xfrm>
+          <a:prstGeom prst="roundRect">
+            <a:avLst>
+              <a:gd name="adj" fmla="val 6362"/>
+            </a:avLst>
+          </a:prstGeom>
+          <a:solidFill>
+            <a:schemeClr val="bg1"/>
+          </a:solidFill>
+          <a:ln>
+            <a:noFill/>
+          </a:ln>
+          <a:effectLst>
+            <a:outerShdw blurRad="190500" dist="38100" dir="5400000" algn="t" rotWithShape="0">
+              <a:prstClr val="black">
+                <a:alpha val="15000"/>
+              </a:prstClr>
+            </a:outerShdw>
+          </a:effectLst>
+        </p:spPr>
+        <p:style>
+          <a:lnRef idx="2">
+            <a:schemeClr val="accent1">
+              <a:shade val="15000"/>
+            </a:schemeClr>
+          </a:lnRef>
+          <a:fillRef idx="1">
+            <a:schemeClr val="accent1"/>
+          </a:fillRef>
+          <a:effectRef idx="0">
+            <a:schemeClr val="accent1"/>
+          </a:effectRef>
+          <a:fontRef idx="minor">
+            <a:schemeClr val="lt1"/>
+          </a:fontRef>
+        </p:style>
+        <p:txBody>
+          <a:bodyPr rtlCol="0" anchor="ctr"/>
+          <a:lstStyle/>
+          <a:p>
+            <a:pPr algn="ctr"/>
+            <a:endParaRPr lang="en-US" dirty="0"/>
+          </a:p>
+        </p:txBody>
+      </p:sp>
+    </p:spTree>
+    <p:extLst>
+      <p:ext uri="{BB962C8B-B14F-4D97-AF65-F5344CB8AC3E}">
+        <p14:creationId xmlns:p14="http://schemas.microsoft.com/office/powerpoint/2010/main" val="1372068515"/>
+      </p:ext>
+    </p:extLst>
+  </p:cSld>
+  <p:clrMapOvr>
+    <a:masterClrMapping/>
+  </p:clrMapOvr>
+</p:sld>
+</file>
+
+<file path=ppt/slides/slide3.xml><?xml version="1.0" encoding="utf-8"?>
+<p:sld xmlns:a="http://schemas.openxmlformats.org/drawingml/2006/main" xmlns:r="http://schemas.openxmlformats.org/officeDocument/2006/relationships" xmlns:p="http://schemas.openxmlformats.org/presentationml/2006/main">
+  <p:cSld>
+    <p:spTree>
+      <p:nvGrpSpPr>
+        <p:cNvPr id="1" name="">
+          <a:extLst>
+            <a:ext uri="{FF2B5EF4-FFF2-40B4-BE49-F238E27FC236}">
+              <a16:creationId xmlns:a16="http://schemas.microsoft.com/office/drawing/2014/main" id="{96491797-68D4-94FC-1EAB-5054F79E2D45}"/>
+            </a:ext>
+          </a:extLst>
+        </p:cNvPr>
+        <p:cNvGrpSpPr/>
+        <p:nvPr/>
+      </p:nvGrpSpPr>
+      <p:grpSpPr>
+        <a:xfrm>
+          <a:off x="0" y="0"/>
+          <a:ext cx="0" cy="0"/>
+          <a:chOff x="0" y="0"/>
+          <a:chExt cx="0" cy="0"/>
+        </a:xfrm>
+      </p:grpSpPr>
+      <p:sp>
+        <p:nvSpPr>
+          <p:cNvPr id="5" name="Rectangle 4">
+            <a:extLst>
+              <a:ext uri="{FF2B5EF4-FFF2-40B4-BE49-F238E27FC236}">
+                <a16:creationId xmlns:a16="http://schemas.microsoft.com/office/drawing/2014/main" id="{B8FAB81B-BC67-F400-EA0C-0E9BDFED46D7}"/>
+              </a:ext>
+            </a:extLst>
+          </p:cNvPr>
+          <p:cNvSpPr/>
+          <p:nvPr/>
+        </p:nvSpPr>
+        <p:spPr>
+          <a:xfrm>
+            <a:off x="0" y="0"/>
+            <a:ext cx="13716000" cy="9144000"/>
+          </a:xfrm>
+          <a:prstGeom prst="rect">
+            <a:avLst/>
+          </a:prstGeom>
+          <a:solidFill>
+            <a:srgbClr val="ECEAF7"/>
+          </a:solidFill>
+          <a:ln>
+            <a:noFill/>
+          </a:ln>
+        </p:spPr>
+        <p:style>
+          <a:lnRef idx="2">
+            <a:schemeClr val="accent1">
+              <a:shade val="15000"/>
+            </a:schemeClr>
+          </a:lnRef>
+          <a:fillRef idx="1">
+            <a:schemeClr val="accent1"/>
+          </a:fillRef>
+          <a:effectRef idx="0">
+            <a:schemeClr val="accent1"/>
+          </a:effectRef>
+          <a:fontRef idx="minor">
+            <a:schemeClr val="lt1"/>
+          </a:fontRef>
+        </p:style>
+        <p:txBody>
+          <a:bodyPr rtlCol="0" anchor="ctr"/>
+          <a:lstStyle/>
+          <a:p>
+            <a:pPr algn="ctr"/>
+            <a:endParaRPr lang="en-US" dirty="0"/>
+          </a:p>
+        </p:txBody>
+      </p:sp>
+      <p:sp>
+        <p:nvSpPr>
+          <p:cNvPr id="7" name="Rectangle 6">
+            <a:extLst>
+              <a:ext uri="{FF2B5EF4-FFF2-40B4-BE49-F238E27FC236}">
+                <a16:creationId xmlns:a16="http://schemas.microsoft.com/office/drawing/2014/main" id="{306D6931-2168-28CD-A2DD-1008CFB79583}"/>
+              </a:ext>
+            </a:extLst>
+          </p:cNvPr>
+          <p:cNvSpPr/>
+          <p:nvPr/>
+        </p:nvSpPr>
+        <p:spPr>
+          <a:xfrm>
+            <a:off x="0" y="1"/>
+            <a:ext cx="13716000" cy="685800"/>
+          </a:xfrm>
+          <a:prstGeom prst="rect">
+            <a:avLst/>
+          </a:prstGeom>
+          <a:solidFill>
+            <a:schemeClr val="bg1"/>
+          </a:solidFill>
+          <a:ln>
+            <a:noFill/>
+          </a:ln>
+        </p:spPr>
+        <p:style>
+          <a:lnRef idx="2">
+            <a:schemeClr val="accent1">
+              <a:shade val="15000"/>
+            </a:schemeClr>
+          </a:lnRef>
+          <a:fillRef idx="1">
+            <a:schemeClr val="accent1"/>
+          </a:fillRef>
+          <a:effectRef idx="0">
+            <a:schemeClr val="accent1"/>
+          </a:effectRef>
+          <a:fontRef idx="minor">
+            <a:schemeClr val="lt1"/>
+          </a:fontRef>
+        </p:style>
+        <p:txBody>
+          <a:bodyPr rtlCol="0" anchor="ctr"/>
+          <a:lstStyle/>
+          <a:p>
+            <a:pPr algn="ctr"/>
+            <a:endParaRPr lang="en-US"/>
+          </a:p>
+        </p:txBody>
+      </p:sp>
+      <p:sp>
+        <p:nvSpPr>
+          <p:cNvPr id="6" name="Rectangle 5">
+            <a:extLst>
+              <a:ext uri="{FF2B5EF4-FFF2-40B4-BE49-F238E27FC236}">
+                <a16:creationId xmlns:a16="http://schemas.microsoft.com/office/drawing/2014/main" id="{847118D9-6A3C-31F3-FE4C-8FBFCCA79D42}"/>
+              </a:ext>
+            </a:extLst>
+          </p:cNvPr>
+          <p:cNvSpPr/>
+          <p:nvPr/>
+        </p:nvSpPr>
+        <p:spPr>
+          <a:xfrm>
+            <a:off x="0" y="0"/>
+            <a:ext cx="1920240" cy="9144000"/>
+          </a:xfrm>
+          <a:prstGeom prst="rect">
+            <a:avLst/>
+          </a:prstGeom>
+          <a:gradFill>
+            <a:gsLst>
+              <a:gs pos="74845">
+                <a:srgbClr val="9B73FF"/>
+              </a:gs>
+              <a:gs pos="54000">
+                <a:srgbClr val="4C05FF"/>
+              </a:gs>
+              <a:gs pos="100000">
+                <a:schemeClr val="bg1"/>
+              </a:gs>
+            </a:gsLst>
+            <a:lin ang="5400000" scaled="1"/>
+          </a:gradFill>
+          <a:ln>
+            <a:noFill/>
+          </a:ln>
+        </p:spPr>
+        <p:style>
+          <a:lnRef idx="2">
+            <a:schemeClr val="accent1">
+              <a:shade val="15000"/>
+            </a:schemeClr>
+          </a:lnRef>
+          <a:fillRef idx="1">
+            <a:schemeClr val="accent1"/>
+          </a:fillRef>
+          <a:effectRef idx="0">
+            <a:schemeClr val="accent1"/>
+          </a:effectRef>
+          <a:fontRef idx="minor">
+            <a:schemeClr val="lt1"/>
+          </a:fontRef>
+        </p:style>
+        <p:txBody>
+          <a:bodyPr rtlCol="0" anchor="ctr"/>
+          <a:lstStyle/>
+          <a:p>
+            <a:pPr algn="ctr"/>
+            <a:endParaRPr lang="en-US"/>
+          </a:p>
+        </p:txBody>
+      </p:sp>
+      <p:sp>
+        <p:nvSpPr>
+          <p:cNvPr id="2" name="Rectangle: Rounded Corners 1">
+            <a:extLst>
+              <a:ext uri="{FF2B5EF4-FFF2-40B4-BE49-F238E27FC236}">
+                <a16:creationId xmlns:a16="http://schemas.microsoft.com/office/drawing/2014/main" id="{F6E0BDE0-15E6-13BF-A75B-361D53763237}"/>
+              </a:ext>
+            </a:extLst>
+          </p:cNvPr>
+          <p:cNvSpPr/>
+          <p:nvPr/>
+        </p:nvSpPr>
+        <p:spPr>
+          <a:xfrm>
+            <a:off x="2377439" y="1097280"/>
+            <a:ext cx="10886385" cy="2971800"/>
+          </a:xfrm>
+          <a:prstGeom prst="roundRect">
+            <a:avLst>
+              <a:gd name="adj" fmla="val 6362"/>
+            </a:avLst>
+          </a:prstGeom>
+          <a:gradFill>
+            <a:gsLst>
+              <a:gs pos="98000">
+                <a:srgbClr val="FFC905"/>
+              </a:gs>
+              <a:gs pos="39000">
+                <a:srgbClr val="FFEEB1"/>
+              </a:gs>
+              <a:gs pos="75000">
+                <a:srgbClr val="FFDF6A"/>
+              </a:gs>
+              <a:gs pos="0">
+                <a:schemeClr val="bg1"/>
+              </a:gs>
+            </a:gsLst>
+            <a:lin ang="16200000" scaled="0"/>
+          </a:gradFill>
+          <a:ln>
+            <a:noFill/>
+          </a:ln>
+          <a:effectLst>
+            <a:outerShdw blurRad="190500" dist="38100" dir="5400000" algn="t" rotWithShape="0">
+              <a:prstClr val="black">
+                <a:alpha val="15000"/>
+              </a:prstClr>
+            </a:outerShdw>
+          </a:effectLst>
+        </p:spPr>
+        <p:style>
+          <a:lnRef idx="2">
+            <a:schemeClr val="accent1">
+              <a:shade val="15000"/>
+            </a:schemeClr>
+          </a:lnRef>
+          <a:fillRef idx="1">
+            <a:schemeClr val="accent1"/>
+          </a:fillRef>
+          <a:effectRef idx="0">
+            <a:schemeClr val="accent1"/>
+          </a:effectRef>
+          <a:fontRef idx="minor">
+            <a:schemeClr val="lt1"/>
+          </a:fontRef>
+        </p:style>
+        <p:txBody>
+          <a:bodyPr rtlCol="0" anchor="ctr"/>
+          <a:lstStyle/>
+          <a:p>
+            <a:pPr algn="ctr"/>
+            <a:endParaRPr lang="en-US" dirty="0"/>
+          </a:p>
+        </p:txBody>
+      </p:sp>
+      <p:sp>
+        <p:nvSpPr>
+          <p:cNvPr id="15" name="Rectangle: Rounded Corners 14">
+            <a:extLst>
+              <a:ext uri="{FF2B5EF4-FFF2-40B4-BE49-F238E27FC236}">
+                <a16:creationId xmlns:a16="http://schemas.microsoft.com/office/drawing/2014/main" id="{26104CD1-E22D-78A2-4546-7380723075CD}"/>
+              </a:ext>
+            </a:extLst>
+          </p:cNvPr>
+          <p:cNvSpPr/>
+          <p:nvPr/>
+        </p:nvSpPr>
+        <p:spPr>
+          <a:xfrm>
+            <a:off x="2374927" y="4526280"/>
+            <a:ext cx="3319272" cy="4160520"/>
+          </a:xfrm>
+          <a:prstGeom prst="roundRect">
+            <a:avLst>
+              <a:gd name="adj" fmla="val 6362"/>
+            </a:avLst>
+          </a:prstGeom>
+          <a:solidFill>
+            <a:schemeClr val="bg1"/>
+          </a:solidFill>
+          <a:ln>
+            <a:noFill/>
+          </a:ln>
+          <a:effectLst>
+            <a:outerShdw blurRad="190500" dist="38100" dir="5400000" algn="t" rotWithShape="0">
+              <a:prstClr val="black">
+                <a:alpha val="15000"/>
+              </a:prstClr>
+            </a:outerShdw>
+          </a:effectLst>
+        </p:spPr>
+        <p:style>
+          <a:lnRef idx="2">
+            <a:schemeClr val="accent1">
+              <a:shade val="15000"/>
+            </a:schemeClr>
+          </a:lnRef>
+          <a:fillRef idx="1">
+            <a:schemeClr val="accent1"/>
+          </a:fillRef>
+          <a:effectRef idx="0">
+            <a:schemeClr val="accent1"/>
+          </a:effectRef>
+          <a:fontRef idx="minor">
+            <a:schemeClr val="lt1"/>
+          </a:fontRef>
+        </p:style>
+        <p:txBody>
+          <a:bodyPr rtlCol="0" anchor="ctr"/>
+          <a:lstStyle/>
+          <a:p>
+            <a:pPr algn="ctr"/>
+            <a:endParaRPr lang="en-US" dirty="0"/>
+          </a:p>
+        </p:txBody>
+      </p:sp>
+      <p:sp>
+        <p:nvSpPr>
+          <p:cNvPr id="25" name="Rectangle: Rounded Corners 24">
+            <a:extLst>
+              <a:ext uri="{FF2B5EF4-FFF2-40B4-BE49-F238E27FC236}">
+                <a16:creationId xmlns:a16="http://schemas.microsoft.com/office/drawing/2014/main" id="{A4439735-605A-500E-BD6A-B5C814CCB001}"/>
+              </a:ext>
+            </a:extLst>
+          </p:cNvPr>
+          <p:cNvSpPr/>
+          <p:nvPr/>
+        </p:nvSpPr>
+        <p:spPr>
+          <a:xfrm>
+            <a:off x="6159740" y="4526280"/>
+            <a:ext cx="3319272" cy="4160520"/>
+          </a:xfrm>
+          <a:prstGeom prst="roundRect">
+            <a:avLst>
+              <a:gd name="adj" fmla="val 6362"/>
+            </a:avLst>
+          </a:prstGeom>
+          <a:solidFill>
+            <a:schemeClr val="bg1"/>
+          </a:solidFill>
+          <a:ln>
+            <a:noFill/>
+          </a:ln>
+          <a:effectLst>
+            <a:outerShdw blurRad="190500" dist="38100" dir="5400000" algn="t" rotWithShape="0">
+              <a:prstClr val="black">
+                <a:alpha val="15000"/>
+              </a:prstClr>
+            </a:outerShdw>
+          </a:effectLst>
+        </p:spPr>
+        <p:style>
+          <a:lnRef idx="2">
+            <a:schemeClr val="accent1">
+              <a:shade val="15000"/>
+            </a:schemeClr>
+          </a:lnRef>
+          <a:fillRef idx="1">
+            <a:schemeClr val="accent1"/>
+          </a:fillRef>
+          <a:effectRef idx="0">
+            <a:schemeClr val="accent1"/>
+          </a:effectRef>
+          <a:fontRef idx="minor">
+            <a:schemeClr val="lt1"/>
+          </a:fontRef>
+        </p:style>
+        <p:txBody>
+          <a:bodyPr rtlCol="0" anchor="ctr"/>
+          <a:lstStyle/>
+          <a:p>
+            <a:pPr algn="ctr"/>
+            <a:endParaRPr lang="en-US" dirty="0"/>
+          </a:p>
+        </p:txBody>
+      </p:sp>
+      <p:sp>
+        <p:nvSpPr>
+          <p:cNvPr id="26" name="Rectangle: Rounded Corners 25">
+            <a:extLst>
+              <a:ext uri="{FF2B5EF4-FFF2-40B4-BE49-F238E27FC236}">
+                <a16:creationId xmlns:a16="http://schemas.microsoft.com/office/drawing/2014/main" id="{1F84C571-8796-6563-4004-AF05B94F309A}"/>
+              </a:ext>
+            </a:extLst>
+          </p:cNvPr>
+          <p:cNvSpPr/>
+          <p:nvPr/>
+        </p:nvSpPr>
+        <p:spPr>
+          <a:xfrm>
+            <a:off x="9944552" y="4526280"/>
+            <a:ext cx="3319272" cy="4160520"/>
+          </a:xfrm>
+          <a:prstGeom prst="roundRect">
+            <a:avLst>
+              <a:gd name="adj" fmla="val 6362"/>
+            </a:avLst>
+          </a:prstGeom>
+          <a:solidFill>
+            <a:schemeClr val="bg1"/>
+          </a:solidFill>
+          <a:ln>
+            <a:noFill/>
+          </a:ln>
+          <a:effectLst>
+            <a:outerShdw blurRad="190500" dist="38100" dir="5400000" algn="t" rotWithShape="0">
+              <a:prstClr val="black">
+                <a:alpha val="15000"/>
+              </a:prstClr>
+            </a:outerShdw>
+          </a:effectLst>
+        </p:spPr>
+        <p:style>
+          <a:lnRef idx="2">
+            <a:schemeClr val="accent1">
+              <a:shade val="15000"/>
+            </a:schemeClr>
+          </a:lnRef>
+          <a:fillRef idx="1">
+            <a:schemeClr val="accent1"/>
+          </a:fillRef>
+          <a:effectRef idx="0">
+            <a:schemeClr val="accent1"/>
+          </a:effectRef>
+          <a:fontRef idx="minor">
+            <a:schemeClr val="lt1"/>
+          </a:fontRef>
+        </p:style>
+        <p:txBody>
+          <a:bodyPr rtlCol="0" anchor="ctr"/>
+          <a:lstStyle/>
+          <a:p>
+            <a:pPr algn="ctr"/>
+            <a:endParaRPr lang="en-US" dirty="0"/>
+          </a:p>
+        </p:txBody>
+      </p:sp>
+    </p:spTree>
+    <p:extLst>
+      <p:ext uri="{BB962C8B-B14F-4D97-AF65-F5344CB8AC3E}">
+        <p14:creationId xmlns:p14="http://schemas.microsoft.com/office/powerpoint/2010/main" val="910047241"/>
+      </p:ext>
+    </p:extLst>
+  </p:cSld>
+  <p:clrMapOvr>
+    <a:masterClrMapping/>
+  </p:clrMapOvr>
+</p:sld>
+</file>
+
+<file path=ppt/slides/slide4.xml><?xml version="1.0" encoding="utf-8"?>
+<p:sld xmlns:a="http://schemas.openxmlformats.org/drawingml/2006/main" xmlns:r="http://schemas.openxmlformats.org/officeDocument/2006/relationships" xmlns:p="http://schemas.openxmlformats.org/presentationml/2006/main">
+  <p:cSld>
+    <p:spTree>
+      <p:nvGrpSpPr>
+        <p:cNvPr id="1" name=""/>
+        <p:cNvGrpSpPr/>
+        <p:nvPr/>
+      </p:nvGrpSpPr>
+      <p:grpSpPr>
+        <a:xfrm>
+          <a:off x="0" y="0"/>
+          <a:ext cx="0" cy="0"/>
+          <a:chOff x="0" y="0"/>
+          <a:chExt cx="0" cy="0"/>
+        </a:xfrm>
+      </p:grpSpPr>
+      <p:sp>
+        <p:nvSpPr>
+          <p:cNvPr id="4" name="Rectangle: Rounded Corners 3">
+            <a:extLst>
+              <a:ext uri="{FF2B5EF4-FFF2-40B4-BE49-F238E27FC236}">
+                <a16:creationId xmlns:a16="http://schemas.microsoft.com/office/drawing/2014/main" id="{7E076314-8835-CAC9-3878-96110A389E79}"/>
+              </a:ext>
+            </a:extLst>
+          </p:cNvPr>
+          <p:cNvSpPr/>
+          <p:nvPr/>
+        </p:nvSpPr>
+        <p:spPr>
+          <a:xfrm>
+            <a:off x="2377439" y="1097280"/>
+            <a:ext cx="2551176" cy="1600200"/>
+          </a:xfrm>
+          <a:prstGeom prst="roundRect">
+            <a:avLst>
+              <a:gd name="adj" fmla="val 6362"/>
+            </a:avLst>
+          </a:prstGeom>
+          <a:gradFill>
+            <a:gsLst>
+              <a:gs pos="98000">
+                <a:srgbClr val="FFC905"/>
+              </a:gs>
+              <a:gs pos="39000">
+                <a:srgbClr val="FFEEB1"/>
+              </a:gs>
+              <a:gs pos="75000">
+                <a:srgbClr val="FFDF6A"/>
+              </a:gs>
+              <a:gs pos="0">
+                <a:schemeClr val="bg1"/>
+              </a:gs>
+            </a:gsLst>
+            <a:lin ang="16200000" scaled="0"/>
+          </a:gradFill>
+          <a:ln>
+            <a:noFill/>
+          </a:ln>
+          <a:effectLst>
+            <a:outerShdw blurRad="190500" dist="38100" dir="5400000" algn="t" rotWithShape="0">
+              <a:prstClr val="black">
+                <a:alpha val="15000"/>
+              </a:prstClr>
+            </a:outerShdw>
+          </a:effectLst>
+        </p:spPr>
+        <p:style>
+          <a:lnRef idx="2">
+            <a:schemeClr val="accent1">
+              <a:shade val="15000"/>
+            </a:schemeClr>
+          </a:lnRef>
+          <a:fillRef idx="1">
+            <a:schemeClr val="accent1"/>
+          </a:fillRef>
+          <a:effectRef idx="0">
+            <a:schemeClr val="accent1"/>
+          </a:effectRef>
+          <a:fontRef idx="minor">
+            <a:schemeClr val="lt1"/>
+          </a:fontRef>
+        </p:style>
+        <p:txBody>
+          <a:bodyPr rtlCol="0" anchor="ctr"/>
+          <a:lstStyle/>
+          <a:p>
+            <a:pPr algn="ctr"/>
+            <a:endParaRPr lang="en-US" dirty="0"/>
+          </a:p>
+        </p:txBody>
+      </p:sp>
+    </p:spTree>
+    <p:extLst>
+      <p:ext uri="{BB962C8B-B14F-4D97-AF65-F5344CB8AC3E}">
+        <p14:creationId xmlns:p14="http://schemas.microsoft.com/office/powerpoint/2010/main" val="2961736598"/>
+      </p:ext>
+    </p:extLst>
+  </p:cSld>
+  <p:clrMapOvr>
+    <a:masterClrMapping/>
+  </p:clrMapOvr>
+</p:sld>
+</file>
+
+<file path=ppt/slides/slide5.xml><?xml version="1.0" encoding="utf-8"?>
+<p:sld xmlns:a="http://schemas.openxmlformats.org/drawingml/2006/main" xmlns:r="http://schemas.openxmlformats.org/officeDocument/2006/relationships" xmlns:p="http://schemas.openxmlformats.org/presentationml/2006/main">
+  <p:cSld>
+    <p:spTree>
+      <p:nvGrpSpPr>
+        <p:cNvPr id="1" name=""/>
+        <p:cNvGrpSpPr/>
+        <p:nvPr/>
+      </p:nvGrpSpPr>
+      <p:grpSpPr>
+        <a:xfrm>
+          <a:off x="0" y="0"/>
+          <a:ext cx="0" cy="0"/>
+          <a:chOff x="0" y="0"/>
+          <a:chExt cx="0" cy="0"/>
+        </a:xfrm>
+      </p:grpSpPr>
+      <p:sp>
+        <p:nvSpPr>
           <p:cNvPr id="2" name="Title 1">
             <a:extLst>
               <a:ext uri="{FF2B5EF4-FFF2-40B4-BE49-F238E27FC236}">
@@ -4398,7 +5652,7 @@
           <a:p>
             <a:r>
               <a:rPr lang="en-US" sz="2700" dirty="0"/>
-              <a:t>#005E00</a:t>
+              <a:t>#4C05FF</a:t>
             </a:r>
           </a:p>
         </p:txBody>

</xml_diff>

<commit_message>
Add power bi report file (WIP)
</commit_message>
<xml_diff>
--- a/Sales-performance-report/dataset/designbackground.pptx
+++ b/Sales-performance-report/dataset/designbackground.pptx
@@ -258,7 +258,7 @@
           <a:p>
             <a:fld id="{073D55F9-11A3-4523-8F38-6BA37933791A}" type="datetime1">
               <a:rPr lang="en-US" smtClean="0"/>
-              <a:t>12/28/2025</a:t>
+              <a:t>12/30/2025</a:t>
             </a:fld>
             <a:endParaRPr lang="en-US"/>
           </a:p>
@@ -431,7 +431,7 @@
           <a:p>
             <a:fld id="{0B4E757A-3EC2-4683-9080-1A460C37C843}" type="datetime1">
               <a:rPr lang="en-US" smtClean="0"/>
-              <a:t>12/28/2025</a:t>
+              <a:t>12/30/2025</a:t>
             </a:fld>
             <a:endParaRPr lang="en-US"/>
           </a:p>
@@ -614,7 +614,7 @@
           <a:p>
             <a:fld id="{5CC8096C-64ED-4153-A483-5C02E44AD5C3}" type="datetime1">
               <a:rPr lang="en-US" smtClean="0"/>
-              <a:t>12/28/2025</a:t>
+              <a:t>12/30/2025</a:t>
             </a:fld>
             <a:endParaRPr lang="en-US" dirty="0"/>
           </a:p>
@@ -787,7 +787,7 @@
           <a:p>
             <a:fld id="{1CB9D56B-6EBE-4E5F-99D9-2A3DBDF37D0A}" type="datetime1">
               <a:rPr lang="en-US" smtClean="0"/>
-              <a:t>12/28/2025</a:t>
+              <a:t>12/30/2025</a:t>
             </a:fld>
             <a:endParaRPr lang="en-US"/>
           </a:p>
@@ -1036,7 +1036,7 @@
           <a:p>
             <a:fld id="{8C33F3CA-C7E3-432D-9282-18F13836509A}" type="datetime1">
               <a:rPr lang="en-US" smtClean="0"/>
-              <a:t>12/28/2025</a:t>
+              <a:t>12/30/2025</a:t>
             </a:fld>
             <a:endParaRPr lang="en-US" dirty="0"/>
           </a:p>
@@ -1271,7 +1271,7 @@
           <a:p>
             <a:fld id="{75BE9C62-1337-40B8-BA50-E9F4861DB4BC}" type="datetime1">
               <a:rPr lang="en-US" smtClean="0"/>
-              <a:t>12/28/2025</a:t>
+              <a:t>12/30/2025</a:t>
             </a:fld>
             <a:endParaRPr lang="en-US"/>
           </a:p>
@@ -1641,7 +1641,7 @@
           <a:p>
             <a:fld id="{47C195EB-2DA3-4B24-8725-19BC22A7BE50}" type="datetime1">
               <a:rPr lang="en-US" smtClean="0"/>
-              <a:t>12/28/2025</a:t>
+              <a:t>12/30/2025</a:t>
             </a:fld>
             <a:endParaRPr lang="en-US"/>
           </a:p>
@@ -1762,7 +1762,7 @@
           <a:p>
             <a:fld id="{F4E237E6-0076-4915-A5A8-B7C11FA4F374}" type="datetime1">
               <a:rPr lang="en-US" smtClean="0"/>
-              <a:t>12/28/2025</a:t>
+              <a:t>12/30/2025</a:t>
             </a:fld>
             <a:endParaRPr lang="en-US"/>
           </a:p>
@@ -1860,7 +1860,7 @@
           <a:p>
             <a:fld id="{3505F58F-C0B5-422A-8E5A-6B99E5D80F0A}" type="datetime1">
               <a:rPr lang="en-US" smtClean="0"/>
-              <a:t>12/28/2025</a:t>
+              <a:t>12/30/2025</a:t>
             </a:fld>
             <a:endParaRPr lang="en-US"/>
           </a:p>
@@ -2140,7 +2140,7 @@
           <a:p>
             <a:fld id="{7565E655-9687-48DF-A33F-F8824CCCB5D1}" type="datetime1">
               <a:rPr lang="en-US" smtClean="0"/>
-              <a:t>12/28/2025</a:t>
+              <a:t>12/30/2025</a:t>
             </a:fld>
             <a:endParaRPr lang="en-US"/>
           </a:p>
@@ -2400,7 +2400,7 @@
           <a:p>
             <a:fld id="{B97FD56A-AAB8-4544-A495-D0645413C9E3}" type="datetime1">
               <a:rPr lang="en-US" smtClean="0"/>
-              <a:t>12/28/2025</a:t>
+              <a:t>12/30/2025</a:t>
             </a:fld>
             <a:endParaRPr lang="en-US"/>
           </a:p>
@@ -2617,7 +2617,7 @@
             <a:fld id="{193BAB95-8DA7-460B-B00A-7037C8394FB0}" type="datetime1">
               <a:rPr lang="en-US" smtClean="0"/>
               <a:pPr/>
-              <a:t>12/28/2025</a:t>
+              <a:t>12/30/2025</a:t>
             </a:fld>
             <a:endParaRPr lang="en-US" dirty="0"/>
           </a:p>
@@ -5129,6 +5129,21 @@
           <a:bodyPr/>
           <a:lstStyle/>
           <a:p>
+            <a:r>
+              <a:rPr lang="en-US" dirty="0"/>
+              <a:t>#00963C</a:t>
+            </a:r>
+            <a:r>
+              <a:rPr lang="en-US"/>
+              <a:t>: green</a:t>
+            </a:r>
+            <a:br>
+              <a:rPr lang="en-US"/>
+            </a:br>
+            <a:r>
+              <a:rPr lang="en-US"/>
+              <a:t>#F60000: red</a:t>
+            </a:r>
             <a:endParaRPr lang="en-US" dirty="0"/>
           </a:p>
         </p:txBody>

</xml_diff>

<commit_message>
Add power bi report filé
</commit_message>
<xml_diff>
--- a/Sales-performance-report/dataset/designbackground.pptx
+++ b/Sales-performance-report/dataset/designbackground.pptx
@@ -258,7 +258,7 @@
           <a:p>
             <a:fld id="{073D55F9-11A3-4523-8F38-6BA37933791A}" type="datetime1">
               <a:rPr lang="en-US" smtClean="0"/>
-              <a:t>12/30/2025</a:t>
+              <a:t>1/1/2026</a:t>
             </a:fld>
             <a:endParaRPr lang="en-US"/>
           </a:p>
@@ -431,7 +431,7 @@
           <a:p>
             <a:fld id="{0B4E757A-3EC2-4683-9080-1A460C37C843}" type="datetime1">
               <a:rPr lang="en-US" smtClean="0"/>
-              <a:t>12/30/2025</a:t>
+              <a:t>1/1/2026</a:t>
             </a:fld>
             <a:endParaRPr lang="en-US"/>
           </a:p>
@@ -614,7 +614,7 @@
           <a:p>
             <a:fld id="{5CC8096C-64ED-4153-A483-5C02E44AD5C3}" type="datetime1">
               <a:rPr lang="en-US" smtClean="0"/>
-              <a:t>12/30/2025</a:t>
+              <a:t>1/1/2026</a:t>
             </a:fld>
             <a:endParaRPr lang="en-US" dirty="0"/>
           </a:p>
@@ -787,7 +787,7 @@
           <a:p>
             <a:fld id="{1CB9D56B-6EBE-4E5F-99D9-2A3DBDF37D0A}" type="datetime1">
               <a:rPr lang="en-US" smtClean="0"/>
-              <a:t>12/30/2025</a:t>
+              <a:t>1/1/2026</a:t>
             </a:fld>
             <a:endParaRPr lang="en-US"/>
           </a:p>
@@ -1036,7 +1036,7 @@
           <a:p>
             <a:fld id="{8C33F3CA-C7E3-432D-9282-18F13836509A}" type="datetime1">
               <a:rPr lang="en-US" smtClean="0"/>
-              <a:t>12/30/2025</a:t>
+              <a:t>1/1/2026</a:t>
             </a:fld>
             <a:endParaRPr lang="en-US" dirty="0"/>
           </a:p>
@@ -1271,7 +1271,7 @@
           <a:p>
             <a:fld id="{75BE9C62-1337-40B8-BA50-E9F4861DB4BC}" type="datetime1">
               <a:rPr lang="en-US" smtClean="0"/>
-              <a:t>12/30/2025</a:t>
+              <a:t>1/1/2026</a:t>
             </a:fld>
             <a:endParaRPr lang="en-US"/>
           </a:p>
@@ -1641,7 +1641,7 @@
           <a:p>
             <a:fld id="{47C195EB-2DA3-4B24-8725-19BC22A7BE50}" type="datetime1">
               <a:rPr lang="en-US" smtClean="0"/>
-              <a:t>12/30/2025</a:t>
+              <a:t>1/1/2026</a:t>
             </a:fld>
             <a:endParaRPr lang="en-US"/>
           </a:p>
@@ -1762,7 +1762,7 @@
           <a:p>
             <a:fld id="{F4E237E6-0076-4915-A5A8-B7C11FA4F374}" type="datetime1">
               <a:rPr lang="en-US" smtClean="0"/>
-              <a:t>12/30/2025</a:t>
+              <a:t>1/1/2026</a:t>
             </a:fld>
             <a:endParaRPr lang="en-US"/>
           </a:p>
@@ -1860,7 +1860,7 @@
           <a:p>
             <a:fld id="{3505F58F-C0B5-422A-8E5A-6B99E5D80F0A}" type="datetime1">
               <a:rPr lang="en-US" smtClean="0"/>
-              <a:t>12/30/2025</a:t>
+              <a:t>1/1/2026</a:t>
             </a:fld>
             <a:endParaRPr lang="en-US"/>
           </a:p>
@@ -2140,7 +2140,7 @@
           <a:p>
             <a:fld id="{7565E655-9687-48DF-A33F-F8824CCCB5D1}" type="datetime1">
               <a:rPr lang="en-US" smtClean="0"/>
-              <a:t>12/30/2025</a:t>
+              <a:t>1/1/2026</a:t>
             </a:fld>
             <a:endParaRPr lang="en-US"/>
           </a:p>
@@ -2400,7 +2400,7 @@
           <a:p>
             <a:fld id="{B97FD56A-AAB8-4544-A495-D0645413C9E3}" type="datetime1">
               <a:rPr lang="en-US" smtClean="0"/>
-              <a:t>12/30/2025</a:t>
+              <a:t>1/1/2026</a:t>
             </a:fld>
             <a:endParaRPr lang="en-US"/>
           </a:p>
@@ -2617,7 +2617,7 @@
             <a:fld id="{193BAB95-8DA7-460B-B00A-7037C8394FB0}" type="datetime1">
               <a:rPr lang="en-US" smtClean="0"/>
               <a:pPr/>
-              <a:t>12/30/2025</a:t>
+              <a:t>1/1/2026</a:t>
             </a:fld>
             <a:endParaRPr lang="en-US" dirty="0"/>
           </a:p>
@@ -3022,13 +3022,31 @@
       <p:bgPr>
         <a:gradFill>
           <a:gsLst>
-            <a:gs pos="100000">
-              <a:srgbClr val="05B8FF">
-                <a:alpha val="10000"/>
-              </a:srgbClr>
+            <a:gs pos="0">
+              <a:srgbClr val="B8C0FF"/>
+            </a:gs>
+            <a:gs pos="40000">
+              <a:srgbClr val="BFCDFF"/>
+            </a:gs>
+            <a:gs pos="30000">
+              <a:srgbClr val="BCC7FF"/>
             </a:gs>
             <a:gs pos="0">
-              <a:schemeClr val="bg1"/>
+              <a:srgbClr val="B6BCFF"/>
+            </a:gs>
+            <a:gs pos="0">
+              <a:srgbClr val="ACABFF"/>
+            </a:gs>
+            <a:gs pos="68000">
+              <a:srgbClr val="D5F3FF"/>
+            </a:gs>
+            <a:gs pos="97000">
+              <a:srgbClr val="D5F3FF"/>
+            </a:gs>
+            <a:gs pos="0">
+              <a:srgbClr val="4C05FF">
+                <a:alpha val="9804"/>
+              </a:srgbClr>
             </a:gs>
           </a:gsLst>
           <a:lin ang="5400000" scaled="1"/>
@@ -3173,7 +3191,7 @@
         </p:nvGrpSpPr>
         <p:grpSpPr>
           <a:xfrm>
-            <a:off x="8463837" y="3195287"/>
+            <a:off x="8485472" y="4147369"/>
             <a:ext cx="955548" cy="804672"/>
             <a:chOff x="2881952" y="4324839"/>
             <a:chExt cx="955548" cy="804672"/>
@@ -3359,7 +3377,7 @@
         </p:nvGrpSpPr>
         <p:grpSpPr>
           <a:xfrm>
-            <a:off x="8463837" y="4330937"/>
+            <a:off x="8485472" y="5044737"/>
             <a:ext cx="955548" cy="804672"/>
             <a:chOff x="2881952" y="4324839"/>
             <a:chExt cx="955548" cy="804672"/>
@@ -3545,7 +3563,7 @@
         </p:nvGrpSpPr>
         <p:grpSpPr>
           <a:xfrm>
-            <a:off x="8463837" y="5466587"/>
+            <a:off x="8485472" y="5919791"/>
             <a:ext cx="955548" cy="804672"/>
             <a:chOff x="2881952" y="4324839"/>
             <a:chExt cx="955548" cy="804672"/>
@@ -3733,7 +3751,7 @@
         </p:nvSpPr>
         <p:spPr>
           <a:xfrm>
-            <a:off x="8639859" y="6602237"/>
+            <a:off x="8586056" y="6926994"/>
             <a:ext cx="603504" cy="603504"/>
           </a:xfrm>
           <a:prstGeom prst="ellipse">
@@ -3769,7 +3787,7 @@
           <a:lstStyle/>
           <a:p>
             <a:pPr algn="ctr"/>
-            <a:endParaRPr lang="en-US"/>
+            <a:endParaRPr lang="en-US" dirty="0"/>
           </a:p>
         </p:txBody>
       </p:sp>
@@ -3787,7 +3805,7 @@
         </p:nvSpPr>
         <p:spPr>
           <a:xfrm>
-            <a:off x="8639859" y="7536721"/>
+            <a:off x="8586056" y="7777220"/>
             <a:ext cx="603504" cy="603504"/>
           </a:xfrm>
           <a:prstGeom prst="ellipse">
@@ -4674,14 +4692,14 @@
           </a:prstGeom>
           <a:gradFill>
             <a:gsLst>
-              <a:gs pos="74845">
+              <a:gs pos="72000">
                 <a:srgbClr val="9B73FF"/>
               </a:gs>
-              <a:gs pos="54000">
+              <a:gs pos="48000">
                 <a:srgbClr val="4C05FF"/>
               </a:gs>
-              <a:gs pos="100000">
-                <a:schemeClr val="bg1"/>
+              <a:gs pos="98000">
+                <a:srgbClr val="ECEAF7"/>
               </a:gs>
             </a:gsLst>
             <a:lin ang="5400000" scaled="1"/>

</xml_diff>